<commit_message>
테스트 계획서 PPT: prisma mock 테스트 결과 반영 + prisma generate 이슈 기록
</commit_message>
<xml_diff>
--- a/doc/ScoreCaddie_테스트계획서.pptx
+++ b/doc/ScoreCaddie_테스트계획서.pptx
@@ -3312,10 +3312,10 @@
                       <a:r>
                         <a:rPr lang="en-US" sz="1100" b="1" dirty="0">
                           <a:solidFill>
-                            <a:srgbClr val="8A9A9C"/>
+                            <a:srgbClr val="0B8457"/>
                           </a:solidFill>
                         </a:rPr>
-                        <a:t>예정</a:t>
+                        <a:t>통과</a:t>
                       </a:r>
                       <a:endParaRPr lang="en-US" sz="1100" dirty="0"/>
                     </a:p>
@@ -3352,7 +3352,7 @@
                             <a:srgbClr val="17282A"/>
                           </a:solidFill>
                         </a:rPr>
-                        <a:t>-</a:t>
+                        <a:t>2026-07-28</a:t>
                       </a:r>
                       <a:endParaRPr lang="en-US" sz="1100" dirty="0"/>
                     </a:p>
@@ -3389,7 +3389,7 @@
                             <a:srgbClr val="17282A"/>
                           </a:solidFill>
                         </a:rPr>
-                        <a:t>prisma mock 필요</a:t>
+                        <a:t>2개 케이스(vi.mock으로 prisma 직접 대체)</a:t>
                       </a:r>
                       <a:endParaRPr lang="en-US" sz="1100" dirty="0"/>
                     </a:p>
@@ -3499,10 +3499,10 @@
                       <a:r>
                         <a:rPr lang="en-US" sz="1100" b="1" dirty="0">
                           <a:solidFill>
-                            <a:srgbClr val="8A9A9C"/>
+                            <a:srgbClr val="0B8457"/>
                           </a:solidFill>
                         </a:rPr>
-                        <a:t>예정</a:t>
+                        <a:t>통과</a:t>
                       </a:r>
                       <a:endParaRPr lang="en-US" sz="1100" dirty="0"/>
                     </a:p>
@@ -3539,7 +3539,7 @@
                             <a:srgbClr val="17282A"/>
                           </a:solidFill>
                         </a:rPr>
-                        <a:t>-</a:t>
+                        <a:t>2026-07-28</a:t>
                       </a:r>
                       <a:endParaRPr lang="en-US" sz="1100" dirty="0"/>
                     </a:p>
@@ -3576,7 +3576,7 @@
                             <a:srgbClr val="17282A"/>
                           </a:solidFill>
                         </a:rPr>
-                        <a:t>prisma mock 필요</a:t>
+                        <a:t>6개 케이스(vitest-mock-extended mockDeep 사용)</a:t>
                       </a:r>
                       <a:endParaRPr lang="en-US" sz="1100" dirty="0"/>
                     </a:p>

</xml_diff>